<commit_message>
Regenerate reproducible presentation deck
Co-authored-by: lienleds <231399996+lienleds@users.noreply.github.com>
</commit_message>
<xml_diff>
--- a/customer_purchase_prediction.pptx
+++ b/customer_purchase_prediction.pptx
@@ -6691,7 +6691,7 @@
               </a:defRPr>
             </a:pPr>
             <a:r>
-              <a:t>Training time: &lt;measure during run&gt;</a:t>
+              <a:t>Training time: &lt;dataset required&gt;</a:t>
             </a:r>
           </a:p>
           <a:p>
@@ -6707,7 +6707,7 @@
               </a:defRPr>
             </a:pPr>
             <a:r>
-              <a:t>Prediction latency: &lt;measure during run&gt;</a:t>
+              <a:t>Prediction latency: &lt;dataset required&gt;</a:t>
             </a:r>
           </a:p>
         </p:txBody>
@@ -6841,7 +6841,7 @@
               </a:defRPr>
             </a:pPr>
             <a:r>
-              <a:t>Use its output for accuracy and confusion matrix values</a:t>
+              <a:t>Use its output for confusion matrix values</a:t>
             </a:r>
           </a:p>
           <a:p>
@@ -6857,7 +6857,7 @@
               </a:defRPr>
             </a:pPr>
             <a:r>
-              <a:t>Measure fit/predict with time.perf_counter for runtime metrics</a:t>
+              <a:t>Rerun this generator after adding Social_Network_Ads.csv to embed exact metrics</a:t>
             </a:r>
           </a:p>
         </p:txBody>

</xml_diff>